<commit_message>
Filter elections, add partisan bins, update PPTX
Update compare-plans-dra/_DRA_elections.R to inspect and limit elections, compute margins, and bin districts by partisan lean. Adds unique(out$election), filters to president-2016 and president-2020, comments out an ad-hoc write.csv, converts vote shares to margins around 50%, defines breakpoints and labels, and populates bin_old and bin_new with categorized ranges (with table outputs for inspection). Also includes binary updates to SC/SC-2022-2026-change.pptx and mid-decade-redistricting/_current-map.pptx.
</commit_message>
<xml_diff>
--- a/SC/SC-2022-2026-change.pptx
+++ b/SC/SC-2022-2026-change.pptx
@@ -5,10 +5,11 @@
     <p:sldMasterId id="2147483648" r:id="rId1"/>
   </p:sldMasterIdLst>
   <p:notesMasterIdLst>
-    <p:notesMasterId r:id="rId3"/>
+    <p:notesMasterId r:id="rId4"/>
   </p:notesMasterIdLst>
   <p:sldIdLst>
     <p:sldId id="256" r:id="rId2"/>
+    <p:sldId id="257" r:id="rId3"/>
   </p:sldIdLst>
   <p:sldSz cx="12192000" cy="6858000"/>
   <p:notesSz cx="6858000" cy="9144000"/>
@@ -197,7 +198,7 @@
           <a:p>
             <a:fld id="{2DCA9576-471A-484F-ACFB-2E7CC0D1D788}" type="datetimeFigureOut">
               <a:rPr lang="en-US" smtClean="0"/>
-              <a:t>5/11/26</a:t>
+              <a:t>5/19/26</a:t>
             </a:fld>
             <a:endParaRPr lang="en-US"/>
           </a:p>
@@ -695,7 +696,7 @@
           <a:p>
             <a:fld id="{CDED41C1-AEE7-2C40-93FD-63DB12F1EB88}" type="datetimeFigureOut">
               <a:rPr lang="en-US" smtClean="0"/>
-              <a:t>5/11/26</a:t>
+              <a:t>5/19/26</a:t>
             </a:fld>
             <a:endParaRPr lang="en-US"/>
           </a:p>
@@ -893,7 +894,7 @@
           <a:p>
             <a:fld id="{CDED41C1-AEE7-2C40-93FD-63DB12F1EB88}" type="datetimeFigureOut">
               <a:rPr lang="en-US" smtClean="0"/>
-              <a:t>5/11/26</a:t>
+              <a:t>5/19/26</a:t>
             </a:fld>
             <a:endParaRPr lang="en-US"/>
           </a:p>
@@ -1101,7 +1102,7 @@
           <a:p>
             <a:fld id="{CDED41C1-AEE7-2C40-93FD-63DB12F1EB88}" type="datetimeFigureOut">
               <a:rPr lang="en-US" smtClean="0"/>
-              <a:t>5/11/26</a:t>
+              <a:t>5/19/26</a:t>
             </a:fld>
             <a:endParaRPr lang="en-US"/>
           </a:p>
@@ -1299,7 +1300,7 @@
           <a:p>
             <a:fld id="{CDED41C1-AEE7-2C40-93FD-63DB12F1EB88}" type="datetimeFigureOut">
               <a:rPr lang="en-US" smtClean="0"/>
-              <a:t>5/11/26</a:t>
+              <a:t>5/19/26</a:t>
             </a:fld>
             <a:endParaRPr lang="en-US"/>
           </a:p>
@@ -1574,7 +1575,7 @@
           <a:p>
             <a:fld id="{CDED41C1-AEE7-2C40-93FD-63DB12F1EB88}" type="datetimeFigureOut">
               <a:rPr lang="en-US" smtClean="0"/>
-              <a:t>5/11/26</a:t>
+              <a:t>5/19/26</a:t>
             </a:fld>
             <a:endParaRPr lang="en-US"/>
           </a:p>
@@ -1839,7 +1840,7 @@
           <a:p>
             <a:fld id="{CDED41C1-AEE7-2C40-93FD-63DB12F1EB88}" type="datetimeFigureOut">
               <a:rPr lang="en-US" smtClean="0"/>
-              <a:t>5/11/26</a:t>
+              <a:t>5/19/26</a:t>
             </a:fld>
             <a:endParaRPr lang="en-US"/>
           </a:p>
@@ -2251,7 +2252,7 @@
           <a:p>
             <a:fld id="{CDED41C1-AEE7-2C40-93FD-63DB12F1EB88}" type="datetimeFigureOut">
               <a:rPr lang="en-US" smtClean="0"/>
-              <a:t>5/11/26</a:t>
+              <a:t>5/19/26</a:t>
             </a:fld>
             <a:endParaRPr lang="en-US"/>
           </a:p>
@@ -2392,7 +2393,7 @@
           <a:p>
             <a:fld id="{CDED41C1-AEE7-2C40-93FD-63DB12F1EB88}" type="datetimeFigureOut">
               <a:rPr lang="en-US" smtClean="0"/>
-              <a:t>5/11/26</a:t>
+              <a:t>5/19/26</a:t>
             </a:fld>
             <a:endParaRPr lang="en-US"/>
           </a:p>
@@ -2505,7 +2506,7 @@
           <a:p>
             <a:fld id="{CDED41C1-AEE7-2C40-93FD-63DB12F1EB88}" type="datetimeFigureOut">
               <a:rPr lang="en-US" smtClean="0"/>
-              <a:t>5/11/26</a:t>
+              <a:t>5/19/26</a:t>
             </a:fld>
             <a:endParaRPr lang="en-US"/>
           </a:p>
@@ -2816,7 +2817,7 @@
           <a:p>
             <a:fld id="{CDED41C1-AEE7-2C40-93FD-63DB12F1EB88}" type="datetimeFigureOut">
               <a:rPr lang="en-US" smtClean="0"/>
-              <a:t>5/11/26</a:t>
+              <a:t>5/19/26</a:t>
             </a:fld>
             <a:endParaRPr lang="en-US"/>
           </a:p>
@@ -3104,7 +3105,7 @@
           <a:p>
             <a:fld id="{CDED41C1-AEE7-2C40-93FD-63DB12F1EB88}" type="datetimeFigureOut">
               <a:rPr lang="en-US" smtClean="0"/>
-              <a:t>5/11/26</a:t>
+              <a:t>5/19/26</a:t>
             </a:fld>
             <a:endParaRPr lang="en-US"/>
           </a:p>
@@ -3345,7 +3346,7 @@
           <a:p>
             <a:fld id="{CDED41C1-AEE7-2C40-93FD-63DB12F1EB88}" type="datetimeFigureOut">
               <a:rPr lang="en-US" smtClean="0"/>
-              <a:t>5/11/26</a:t>
+              <a:t>5/19/26</a:t>
             </a:fld>
             <a:endParaRPr lang="en-US"/>
           </a:p>
@@ -4151,6 +4152,1929 @@
     <p:extLst>
       <p:ext uri="{BB962C8B-B14F-4D97-AF65-F5344CB8AC3E}">
         <p14:creationId xmlns:p14="http://schemas.microsoft.com/office/powerpoint/2010/main" val="3208764043"/>
+      </p:ext>
+    </p:extLst>
+  </p:cSld>
+  <p:clrMapOvr>
+    <a:masterClrMapping/>
+  </p:clrMapOvr>
+</p:sld>
+</file>
+
+<file path=ppt/slides/slide2.xml><?xml version="1.0" encoding="utf-8"?>
+<p:sld xmlns:a="http://schemas.openxmlformats.org/drawingml/2006/main" xmlns:r="http://schemas.openxmlformats.org/officeDocument/2006/relationships" xmlns:p="http://schemas.openxmlformats.org/presentationml/2006/main">
+  <p:cSld>
+    <p:spTree>
+      <p:nvGrpSpPr>
+        <p:cNvPr id="1" name=""/>
+        <p:cNvGrpSpPr/>
+        <p:nvPr/>
+      </p:nvGrpSpPr>
+      <p:grpSpPr>
+        <a:xfrm>
+          <a:off x="0" y="0"/>
+          <a:ext cx="0" cy="0"/>
+          <a:chOff x="0" y="0"/>
+          <a:chExt cx="0" cy="0"/>
+        </a:xfrm>
+      </p:grpSpPr>
+      <p:sp>
+        <p:nvSpPr>
+          <p:cNvPr id="46" name="Rectangle 45">
+            <a:extLst>
+              <a:ext uri="{FF2B5EF4-FFF2-40B4-BE49-F238E27FC236}">
+                <a16:creationId xmlns:a16="http://schemas.microsoft.com/office/drawing/2014/main" id="{46717B6F-5F2B-F499-6096-CCDF85B00385}"/>
+              </a:ext>
+            </a:extLst>
+          </p:cNvPr>
+          <p:cNvSpPr/>
+          <p:nvPr/>
+        </p:nvSpPr>
+        <p:spPr>
+          <a:xfrm>
+            <a:off x="4709034" y="1192162"/>
+            <a:ext cx="3542072" cy="5297129"/>
+          </a:xfrm>
+          <a:prstGeom prst="rect">
+            <a:avLst/>
+          </a:prstGeom>
+          <a:solidFill>
+            <a:srgbClr val="F9D382">
+              <a:alpha val="25000"/>
+            </a:srgbClr>
+          </a:solidFill>
+          <a:ln>
+            <a:noFill/>
+          </a:ln>
+        </p:spPr>
+        <p:style>
+          <a:lnRef idx="2">
+            <a:schemeClr val="accent1">
+              <a:shade val="15000"/>
+            </a:schemeClr>
+          </a:lnRef>
+          <a:fillRef idx="1">
+            <a:schemeClr val="accent1"/>
+          </a:fillRef>
+          <a:effectRef idx="0">
+            <a:schemeClr val="accent1"/>
+          </a:effectRef>
+          <a:fontRef idx="minor">
+            <a:schemeClr val="lt1"/>
+          </a:fontRef>
+        </p:style>
+        <p:txBody>
+          <a:bodyPr rtlCol="0" anchor="ctr"/>
+          <a:lstStyle/>
+          <a:p>
+            <a:pPr algn="ctr"/>
+            <a:endParaRPr lang="en-US"/>
+          </a:p>
+        </p:txBody>
+      </p:sp>
+      <p:sp>
+        <p:nvSpPr>
+          <p:cNvPr id="2" name="Rectangle 1">
+            <a:extLst>
+              <a:ext uri="{FF2B5EF4-FFF2-40B4-BE49-F238E27FC236}">
+                <a16:creationId xmlns:a16="http://schemas.microsoft.com/office/drawing/2014/main" id="{F0BDD54E-D69E-78DA-5690-04937A99D60F}"/>
+              </a:ext>
+            </a:extLst>
+          </p:cNvPr>
+          <p:cNvSpPr>
+            <a:spLocks noChangeAspect="1"/>
+          </p:cNvSpPr>
+          <p:nvPr/>
+        </p:nvSpPr>
+        <p:spPr>
+          <a:xfrm>
+            <a:off x="10636357" y="1428137"/>
+            <a:ext cx="457200" cy="457200"/>
+          </a:xfrm>
+          <a:prstGeom prst="rect">
+            <a:avLst/>
+          </a:prstGeom>
+          <a:solidFill>
+            <a:srgbClr val="8CC1EB"/>
+          </a:solidFill>
+          <a:ln>
+            <a:noFill/>
+          </a:ln>
+        </p:spPr>
+        <p:style>
+          <a:lnRef idx="2">
+            <a:schemeClr val="accent1">
+              <a:shade val="15000"/>
+            </a:schemeClr>
+          </a:lnRef>
+          <a:fillRef idx="1">
+            <a:schemeClr val="accent1"/>
+          </a:fillRef>
+          <a:effectRef idx="0">
+            <a:schemeClr val="accent1"/>
+          </a:effectRef>
+          <a:fontRef idx="minor">
+            <a:schemeClr val="lt1"/>
+          </a:fontRef>
+        </p:style>
+        <p:txBody>
+          <a:bodyPr rtlCol="0" anchor="ctr"/>
+          <a:lstStyle/>
+          <a:p>
+            <a:pPr algn="ctr"/>
+            <a:endParaRPr lang="en-US"/>
+          </a:p>
+        </p:txBody>
+      </p:sp>
+      <p:sp>
+        <p:nvSpPr>
+          <p:cNvPr id="3" name="Rectangle 2">
+            <a:extLst>
+              <a:ext uri="{FF2B5EF4-FFF2-40B4-BE49-F238E27FC236}">
+                <a16:creationId xmlns:a16="http://schemas.microsoft.com/office/drawing/2014/main" id="{8FB33F69-2FE4-0AAD-4861-BCCBE6E60136}"/>
+              </a:ext>
+            </a:extLst>
+          </p:cNvPr>
+          <p:cNvSpPr>
+            <a:spLocks noChangeAspect="1"/>
+          </p:cNvSpPr>
+          <p:nvPr/>
+        </p:nvSpPr>
+        <p:spPr>
+          <a:xfrm>
+            <a:off x="1302462" y="1987347"/>
+            <a:ext cx="457200" cy="457200"/>
+          </a:xfrm>
+          <a:prstGeom prst="rect">
+            <a:avLst/>
+          </a:prstGeom>
+          <a:solidFill>
+            <a:srgbClr val="F0A1A0"/>
+          </a:solidFill>
+          <a:ln>
+            <a:noFill/>
+          </a:ln>
+        </p:spPr>
+        <p:style>
+          <a:lnRef idx="2">
+            <a:schemeClr val="accent1">
+              <a:shade val="15000"/>
+            </a:schemeClr>
+          </a:lnRef>
+          <a:fillRef idx="1">
+            <a:schemeClr val="accent1"/>
+          </a:fillRef>
+          <a:effectRef idx="0">
+            <a:schemeClr val="accent1"/>
+          </a:effectRef>
+          <a:fontRef idx="minor">
+            <a:schemeClr val="lt1"/>
+          </a:fontRef>
+        </p:style>
+        <p:txBody>
+          <a:bodyPr rtlCol="0" anchor="ctr"/>
+          <a:lstStyle/>
+          <a:p>
+            <a:pPr algn="ctr"/>
+            <a:endParaRPr lang="en-US"/>
+          </a:p>
+        </p:txBody>
+      </p:sp>
+      <p:sp>
+        <p:nvSpPr>
+          <p:cNvPr id="4" name="Rectangle 3">
+            <a:extLst>
+              <a:ext uri="{FF2B5EF4-FFF2-40B4-BE49-F238E27FC236}">
+                <a16:creationId xmlns:a16="http://schemas.microsoft.com/office/drawing/2014/main" id="{C3A28EE1-B02D-15B6-C8BD-3BBF32849BF0}"/>
+              </a:ext>
+            </a:extLst>
+          </p:cNvPr>
+          <p:cNvSpPr>
+            <a:spLocks noChangeAspect="1"/>
+          </p:cNvSpPr>
+          <p:nvPr/>
+        </p:nvSpPr>
+        <p:spPr>
+          <a:xfrm>
+            <a:off x="732806" y="1999638"/>
+            <a:ext cx="457200" cy="457200"/>
+          </a:xfrm>
+          <a:prstGeom prst="rect">
+            <a:avLst/>
+          </a:prstGeom>
+          <a:solidFill>
+            <a:srgbClr val="F0A1A0"/>
+          </a:solidFill>
+          <a:ln>
+            <a:noFill/>
+          </a:ln>
+        </p:spPr>
+        <p:style>
+          <a:lnRef idx="2">
+            <a:schemeClr val="accent1">
+              <a:shade val="15000"/>
+            </a:schemeClr>
+          </a:lnRef>
+          <a:fillRef idx="1">
+            <a:schemeClr val="accent1"/>
+          </a:fillRef>
+          <a:effectRef idx="0">
+            <a:schemeClr val="accent1"/>
+          </a:effectRef>
+          <a:fontRef idx="minor">
+            <a:schemeClr val="lt1"/>
+          </a:fontRef>
+        </p:style>
+        <p:txBody>
+          <a:bodyPr rtlCol="0" anchor="ctr"/>
+          <a:lstStyle/>
+          <a:p>
+            <a:pPr algn="ctr"/>
+            <a:endParaRPr lang="en-US"/>
+          </a:p>
+        </p:txBody>
+      </p:sp>
+      <p:sp>
+        <p:nvSpPr>
+          <p:cNvPr id="5" name="Rectangle 4">
+            <a:extLst>
+              <a:ext uri="{FF2B5EF4-FFF2-40B4-BE49-F238E27FC236}">
+                <a16:creationId xmlns:a16="http://schemas.microsoft.com/office/drawing/2014/main" id="{948DC3D8-4A5F-5F2B-92BF-DD471FF15B22}"/>
+              </a:ext>
+            </a:extLst>
+          </p:cNvPr>
+          <p:cNvSpPr>
+            <a:spLocks noChangeAspect="1"/>
+          </p:cNvSpPr>
+          <p:nvPr/>
+        </p:nvSpPr>
+        <p:spPr>
+          <a:xfrm>
+            <a:off x="3341125" y="1428137"/>
+            <a:ext cx="457200" cy="457200"/>
+          </a:xfrm>
+          <a:prstGeom prst="rect">
+            <a:avLst/>
+          </a:prstGeom>
+          <a:solidFill>
+            <a:srgbClr val="F0A1A0">
+              <a:alpha val="75000"/>
+            </a:srgbClr>
+          </a:solidFill>
+          <a:ln>
+            <a:noFill/>
+          </a:ln>
+        </p:spPr>
+        <p:style>
+          <a:lnRef idx="2">
+            <a:schemeClr val="accent1">
+              <a:shade val="15000"/>
+            </a:schemeClr>
+          </a:lnRef>
+          <a:fillRef idx="1">
+            <a:schemeClr val="accent1"/>
+          </a:fillRef>
+          <a:effectRef idx="0">
+            <a:schemeClr val="accent1"/>
+          </a:effectRef>
+          <a:fontRef idx="minor">
+            <a:schemeClr val="lt1"/>
+          </a:fontRef>
+        </p:style>
+        <p:txBody>
+          <a:bodyPr rtlCol="0" anchor="ctr"/>
+          <a:lstStyle/>
+          <a:p>
+            <a:pPr algn="ctr"/>
+            <a:endParaRPr lang="en-US"/>
+          </a:p>
+        </p:txBody>
+      </p:sp>
+      <p:sp>
+        <p:nvSpPr>
+          <p:cNvPr id="6" name="Rectangle 5">
+            <a:extLst>
+              <a:ext uri="{FF2B5EF4-FFF2-40B4-BE49-F238E27FC236}">
+                <a16:creationId xmlns:a16="http://schemas.microsoft.com/office/drawing/2014/main" id="{9580B084-371C-F2F4-F4DC-33E69B226997}"/>
+              </a:ext>
+            </a:extLst>
+          </p:cNvPr>
+          <p:cNvSpPr>
+            <a:spLocks noChangeAspect="1"/>
+          </p:cNvSpPr>
+          <p:nvPr/>
+        </p:nvSpPr>
+        <p:spPr>
+          <a:xfrm>
+            <a:off x="1897315" y="1428137"/>
+            <a:ext cx="457200" cy="457200"/>
+          </a:xfrm>
+          <a:prstGeom prst="rect">
+            <a:avLst/>
+          </a:prstGeom>
+          <a:solidFill>
+            <a:srgbClr val="F0A1A0"/>
+          </a:solidFill>
+          <a:ln>
+            <a:noFill/>
+          </a:ln>
+        </p:spPr>
+        <p:style>
+          <a:lnRef idx="2">
+            <a:schemeClr val="accent1">
+              <a:shade val="15000"/>
+            </a:schemeClr>
+          </a:lnRef>
+          <a:fillRef idx="1">
+            <a:schemeClr val="accent1"/>
+          </a:fillRef>
+          <a:effectRef idx="0">
+            <a:schemeClr val="accent1"/>
+          </a:effectRef>
+          <a:fontRef idx="minor">
+            <a:schemeClr val="lt1"/>
+          </a:fontRef>
+        </p:style>
+        <p:txBody>
+          <a:bodyPr rtlCol="0" anchor="ctr"/>
+          <a:lstStyle/>
+          <a:p>
+            <a:pPr algn="ctr"/>
+            <a:endParaRPr lang="en-US"/>
+          </a:p>
+        </p:txBody>
+      </p:sp>
+      <p:sp>
+        <p:nvSpPr>
+          <p:cNvPr id="7" name="Rectangle 6">
+            <a:extLst>
+              <a:ext uri="{FF2B5EF4-FFF2-40B4-BE49-F238E27FC236}">
+                <a16:creationId xmlns:a16="http://schemas.microsoft.com/office/drawing/2014/main" id="{866940FB-A2B6-9CCF-3F2B-8DE1013E666C}"/>
+              </a:ext>
+            </a:extLst>
+          </p:cNvPr>
+          <p:cNvSpPr>
+            <a:spLocks noChangeAspect="1"/>
+          </p:cNvSpPr>
+          <p:nvPr/>
+        </p:nvSpPr>
+        <p:spPr>
+          <a:xfrm>
+            <a:off x="1315983" y="1428137"/>
+            <a:ext cx="457200" cy="457200"/>
+          </a:xfrm>
+          <a:prstGeom prst="rect">
+            <a:avLst/>
+          </a:prstGeom>
+          <a:solidFill>
+            <a:srgbClr val="F0A1A0"/>
+          </a:solidFill>
+          <a:ln>
+            <a:noFill/>
+          </a:ln>
+        </p:spPr>
+        <p:style>
+          <a:lnRef idx="2">
+            <a:schemeClr val="accent1">
+              <a:shade val="15000"/>
+            </a:schemeClr>
+          </a:lnRef>
+          <a:fillRef idx="1">
+            <a:schemeClr val="accent1"/>
+          </a:fillRef>
+          <a:effectRef idx="0">
+            <a:schemeClr val="accent1"/>
+          </a:effectRef>
+          <a:fontRef idx="minor">
+            <a:schemeClr val="lt1"/>
+          </a:fontRef>
+        </p:style>
+        <p:txBody>
+          <a:bodyPr rtlCol="0" anchor="ctr"/>
+          <a:lstStyle/>
+          <a:p>
+            <a:pPr algn="ctr"/>
+            <a:endParaRPr lang="en-US"/>
+          </a:p>
+        </p:txBody>
+      </p:sp>
+      <p:sp>
+        <p:nvSpPr>
+          <p:cNvPr id="8" name="Rectangle 7">
+            <a:extLst>
+              <a:ext uri="{FF2B5EF4-FFF2-40B4-BE49-F238E27FC236}">
+                <a16:creationId xmlns:a16="http://schemas.microsoft.com/office/drawing/2014/main" id="{B34A563C-10B4-0A63-E10F-CEC7EC0B547E}"/>
+              </a:ext>
+            </a:extLst>
+          </p:cNvPr>
+          <p:cNvSpPr>
+            <a:spLocks noChangeAspect="1"/>
+          </p:cNvSpPr>
+          <p:nvPr/>
+        </p:nvSpPr>
+        <p:spPr>
+          <a:xfrm>
+            <a:off x="734651" y="1428137"/>
+            <a:ext cx="457200" cy="457200"/>
+          </a:xfrm>
+          <a:prstGeom prst="rect">
+            <a:avLst/>
+          </a:prstGeom>
+          <a:solidFill>
+            <a:srgbClr val="F0A1A0"/>
+          </a:solidFill>
+          <a:ln>
+            <a:noFill/>
+          </a:ln>
+        </p:spPr>
+        <p:style>
+          <a:lnRef idx="2">
+            <a:schemeClr val="accent1">
+              <a:shade val="15000"/>
+            </a:schemeClr>
+          </a:lnRef>
+          <a:fillRef idx="1">
+            <a:schemeClr val="accent1"/>
+          </a:fillRef>
+          <a:effectRef idx="0">
+            <a:schemeClr val="accent1"/>
+          </a:effectRef>
+          <a:fontRef idx="minor">
+            <a:schemeClr val="lt1"/>
+          </a:fontRef>
+        </p:style>
+        <p:txBody>
+          <a:bodyPr rtlCol="0" anchor="ctr"/>
+          <a:lstStyle/>
+          <a:p>
+            <a:pPr algn="ctr"/>
+            <a:endParaRPr lang="en-US"/>
+          </a:p>
+        </p:txBody>
+      </p:sp>
+      <p:grpSp>
+        <p:nvGrpSpPr>
+          <p:cNvPr id="34" name="Group 33">
+            <a:extLst>
+              <a:ext uri="{FF2B5EF4-FFF2-40B4-BE49-F238E27FC236}">
+                <a16:creationId xmlns:a16="http://schemas.microsoft.com/office/drawing/2014/main" id="{EBD3A585-9CFB-6F57-3E9B-287CE19C0EC4}"/>
+              </a:ext>
+            </a:extLst>
+          </p:cNvPr>
+          <p:cNvGrpSpPr/>
+          <p:nvPr/>
+        </p:nvGrpSpPr>
+        <p:grpSpPr>
+          <a:xfrm>
+            <a:off x="2574206" y="1192162"/>
+            <a:ext cx="1845" cy="5297129"/>
+            <a:chOff x="2289070" y="690716"/>
+            <a:chExt cx="1845" cy="5297129"/>
+          </a:xfrm>
+        </p:grpSpPr>
+        <p:cxnSp>
+          <p:nvCxnSpPr>
+            <p:cNvPr id="10" name="Straight Connector 9">
+              <a:extLst>
+                <a:ext uri="{FF2B5EF4-FFF2-40B4-BE49-F238E27FC236}">
+                  <a16:creationId xmlns:a16="http://schemas.microsoft.com/office/drawing/2014/main" id="{8F5F1E02-517E-9151-F696-8CDA0AAFC8C0}"/>
+                </a:ext>
+              </a:extLst>
+            </p:cNvPr>
+            <p:cNvCxnSpPr>
+              <a:cxnSpLocks/>
+            </p:cNvCxnSpPr>
+            <p:nvPr/>
+          </p:nvCxnSpPr>
+          <p:spPr>
+            <a:xfrm>
+              <a:off x="2290915" y="690716"/>
+              <a:ext cx="0" cy="2286000"/>
+            </a:xfrm>
+            <a:prstGeom prst="line">
+              <a:avLst/>
+            </a:prstGeom>
+            <a:ln>
+              <a:solidFill>
+                <a:schemeClr val="bg1">
+                  <a:lumMod val="75000"/>
+                </a:schemeClr>
+              </a:solidFill>
+              <a:prstDash val="sysDash"/>
+            </a:ln>
+          </p:spPr>
+          <p:style>
+            <a:lnRef idx="2">
+              <a:schemeClr val="accent1"/>
+            </a:lnRef>
+            <a:fillRef idx="0">
+              <a:schemeClr val="accent1"/>
+            </a:fillRef>
+            <a:effectRef idx="1">
+              <a:schemeClr val="accent1"/>
+            </a:effectRef>
+            <a:fontRef idx="minor">
+              <a:schemeClr val="tx1"/>
+            </a:fontRef>
+          </p:style>
+        </p:cxnSp>
+        <p:cxnSp>
+          <p:nvCxnSpPr>
+            <p:cNvPr id="16" name="Straight Connector 15">
+              <a:extLst>
+                <a:ext uri="{FF2B5EF4-FFF2-40B4-BE49-F238E27FC236}">
+                  <a16:creationId xmlns:a16="http://schemas.microsoft.com/office/drawing/2014/main" id="{D3454D73-E0D6-6C19-FE23-A9D2A1DFFC16}"/>
+                </a:ext>
+              </a:extLst>
+            </p:cNvPr>
+            <p:cNvCxnSpPr>
+              <a:cxnSpLocks/>
+            </p:cNvCxnSpPr>
+            <p:nvPr/>
+          </p:nvCxnSpPr>
+          <p:spPr>
+            <a:xfrm>
+              <a:off x="2289070" y="3701845"/>
+              <a:ext cx="0" cy="2286000"/>
+            </a:xfrm>
+            <a:prstGeom prst="line">
+              <a:avLst/>
+            </a:prstGeom>
+            <a:ln>
+              <a:solidFill>
+                <a:schemeClr val="bg1">
+                  <a:lumMod val="75000"/>
+                </a:schemeClr>
+              </a:solidFill>
+              <a:prstDash val="sysDash"/>
+            </a:ln>
+          </p:spPr>
+          <p:style>
+            <a:lnRef idx="2">
+              <a:schemeClr val="accent1"/>
+            </a:lnRef>
+            <a:fillRef idx="0">
+              <a:schemeClr val="accent1"/>
+            </a:fillRef>
+            <a:effectRef idx="1">
+              <a:schemeClr val="accent1"/>
+            </a:effectRef>
+            <a:fontRef idx="minor">
+              <a:schemeClr val="tx1"/>
+            </a:fontRef>
+          </p:style>
+        </p:cxnSp>
+      </p:grpSp>
+      <p:grpSp>
+        <p:nvGrpSpPr>
+          <p:cNvPr id="38" name="Group 37">
+            <a:extLst>
+              <a:ext uri="{FF2B5EF4-FFF2-40B4-BE49-F238E27FC236}">
+                <a16:creationId xmlns:a16="http://schemas.microsoft.com/office/drawing/2014/main" id="{5D8C89C9-07F7-8F13-B55D-3D7FA538BF28}"/>
+              </a:ext>
+            </a:extLst>
+          </p:cNvPr>
+          <p:cNvGrpSpPr/>
+          <p:nvPr/>
+        </p:nvGrpSpPr>
+        <p:grpSpPr>
+          <a:xfrm>
+            <a:off x="10022141" y="1192162"/>
+            <a:ext cx="1845" cy="5297129"/>
+            <a:chOff x="9737005" y="690716"/>
+            <a:chExt cx="1845" cy="5297129"/>
+          </a:xfrm>
+        </p:grpSpPr>
+        <p:cxnSp>
+          <p:nvCxnSpPr>
+            <p:cNvPr id="12" name="Straight Connector 11">
+              <a:extLst>
+                <a:ext uri="{FF2B5EF4-FFF2-40B4-BE49-F238E27FC236}">
+                  <a16:creationId xmlns:a16="http://schemas.microsoft.com/office/drawing/2014/main" id="{EA69BE5B-80D8-FE86-3992-B921F2CFC247}"/>
+                </a:ext>
+              </a:extLst>
+            </p:cNvPr>
+            <p:cNvCxnSpPr>
+              <a:cxnSpLocks/>
+            </p:cNvCxnSpPr>
+            <p:nvPr/>
+          </p:nvCxnSpPr>
+          <p:spPr>
+            <a:xfrm>
+              <a:off x="9738850" y="690716"/>
+              <a:ext cx="0" cy="2286000"/>
+            </a:xfrm>
+            <a:prstGeom prst="line">
+              <a:avLst/>
+            </a:prstGeom>
+            <a:ln>
+              <a:solidFill>
+                <a:schemeClr val="bg1">
+                  <a:lumMod val="75000"/>
+                </a:schemeClr>
+              </a:solidFill>
+              <a:prstDash val="sysDash"/>
+            </a:ln>
+          </p:spPr>
+          <p:style>
+            <a:lnRef idx="2">
+              <a:schemeClr val="accent1"/>
+            </a:lnRef>
+            <a:fillRef idx="0">
+              <a:schemeClr val="accent1"/>
+            </a:fillRef>
+            <a:effectRef idx="1">
+              <a:schemeClr val="accent1"/>
+            </a:effectRef>
+            <a:fontRef idx="minor">
+              <a:schemeClr val="tx1"/>
+            </a:fontRef>
+          </p:style>
+        </p:cxnSp>
+        <p:cxnSp>
+          <p:nvCxnSpPr>
+            <p:cNvPr id="17" name="Straight Connector 16">
+              <a:extLst>
+                <a:ext uri="{FF2B5EF4-FFF2-40B4-BE49-F238E27FC236}">
+                  <a16:creationId xmlns:a16="http://schemas.microsoft.com/office/drawing/2014/main" id="{8354AAA9-50F8-7BD8-E221-1F1E00436E18}"/>
+                </a:ext>
+              </a:extLst>
+            </p:cNvPr>
+            <p:cNvCxnSpPr>
+              <a:cxnSpLocks/>
+            </p:cNvCxnSpPr>
+            <p:nvPr/>
+          </p:nvCxnSpPr>
+          <p:spPr>
+            <a:xfrm>
+              <a:off x="9737005" y="3701845"/>
+              <a:ext cx="0" cy="2286000"/>
+            </a:xfrm>
+            <a:prstGeom prst="line">
+              <a:avLst/>
+            </a:prstGeom>
+            <a:ln>
+              <a:solidFill>
+                <a:schemeClr val="bg1">
+                  <a:lumMod val="75000"/>
+                </a:schemeClr>
+              </a:solidFill>
+              <a:prstDash val="sysDash"/>
+            </a:ln>
+          </p:spPr>
+          <p:style>
+            <a:lnRef idx="2">
+              <a:schemeClr val="accent1"/>
+            </a:lnRef>
+            <a:fillRef idx="0">
+              <a:schemeClr val="accent1"/>
+            </a:fillRef>
+            <a:effectRef idx="1">
+              <a:schemeClr val="accent1"/>
+            </a:effectRef>
+            <a:fontRef idx="minor">
+              <a:schemeClr val="tx1"/>
+            </a:fontRef>
+          </p:style>
+        </p:cxnSp>
+      </p:grpSp>
+      <p:grpSp>
+        <p:nvGrpSpPr>
+          <p:cNvPr id="35" name="Group 34">
+            <a:extLst>
+              <a:ext uri="{FF2B5EF4-FFF2-40B4-BE49-F238E27FC236}">
+                <a16:creationId xmlns:a16="http://schemas.microsoft.com/office/drawing/2014/main" id="{9787DE5A-E4DF-044D-C8CB-42180E6E94EC}"/>
+              </a:ext>
+            </a:extLst>
+          </p:cNvPr>
+          <p:cNvGrpSpPr/>
+          <p:nvPr/>
+        </p:nvGrpSpPr>
+        <p:grpSpPr>
+          <a:xfrm>
+            <a:off x="4709034" y="1192162"/>
+            <a:ext cx="1845" cy="5297129"/>
+            <a:chOff x="4423898" y="690716"/>
+            <a:chExt cx="1845" cy="5297129"/>
+          </a:xfrm>
+        </p:grpSpPr>
+        <p:cxnSp>
+          <p:nvCxnSpPr>
+            <p:cNvPr id="13" name="Straight Connector 12">
+              <a:extLst>
+                <a:ext uri="{FF2B5EF4-FFF2-40B4-BE49-F238E27FC236}">
+                  <a16:creationId xmlns:a16="http://schemas.microsoft.com/office/drawing/2014/main" id="{6D361897-67D4-66D5-E975-0B849F959EF7}"/>
+                </a:ext>
+              </a:extLst>
+            </p:cNvPr>
+            <p:cNvCxnSpPr>
+              <a:cxnSpLocks/>
+            </p:cNvCxnSpPr>
+            <p:nvPr/>
+          </p:nvCxnSpPr>
+          <p:spPr>
+            <a:xfrm>
+              <a:off x="4425743" y="690716"/>
+              <a:ext cx="0" cy="2286000"/>
+            </a:xfrm>
+            <a:prstGeom prst="line">
+              <a:avLst/>
+            </a:prstGeom>
+            <a:ln>
+              <a:solidFill>
+                <a:schemeClr val="tx1">
+                  <a:lumMod val="50000"/>
+                  <a:lumOff val="50000"/>
+                </a:schemeClr>
+              </a:solidFill>
+              <a:prstDash val="sysDash"/>
+            </a:ln>
+          </p:spPr>
+          <p:style>
+            <a:lnRef idx="2">
+              <a:schemeClr val="accent1"/>
+            </a:lnRef>
+            <a:fillRef idx="0">
+              <a:schemeClr val="accent1"/>
+            </a:fillRef>
+            <a:effectRef idx="1">
+              <a:schemeClr val="accent1"/>
+            </a:effectRef>
+            <a:fontRef idx="minor">
+              <a:schemeClr val="tx1"/>
+            </a:fontRef>
+          </p:style>
+        </p:cxnSp>
+        <p:cxnSp>
+          <p:nvCxnSpPr>
+            <p:cNvPr id="18" name="Straight Connector 17">
+              <a:extLst>
+                <a:ext uri="{FF2B5EF4-FFF2-40B4-BE49-F238E27FC236}">
+                  <a16:creationId xmlns:a16="http://schemas.microsoft.com/office/drawing/2014/main" id="{785A599B-40CF-F072-1B4F-DE604D05FAAA}"/>
+                </a:ext>
+              </a:extLst>
+            </p:cNvPr>
+            <p:cNvCxnSpPr>
+              <a:cxnSpLocks/>
+            </p:cNvCxnSpPr>
+            <p:nvPr/>
+          </p:nvCxnSpPr>
+          <p:spPr>
+            <a:xfrm>
+              <a:off x="4423898" y="3701845"/>
+              <a:ext cx="0" cy="2286000"/>
+            </a:xfrm>
+            <a:prstGeom prst="line">
+              <a:avLst/>
+            </a:prstGeom>
+            <a:ln>
+              <a:solidFill>
+                <a:schemeClr val="tx1">
+                  <a:lumMod val="50000"/>
+                  <a:lumOff val="50000"/>
+                </a:schemeClr>
+              </a:solidFill>
+              <a:prstDash val="sysDash"/>
+            </a:ln>
+          </p:spPr>
+          <p:style>
+            <a:lnRef idx="2">
+              <a:schemeClr val="accent1"/>
+            </a:lnRef>
+            <a:fillRef idx="0">
+              <a:schemeClr val="accent1"/>
+            </a:fillRef>
+            <a:effectRef idx="1">
+              <a:schemeClr val="accent1"/>
+            </a:effectRef>
+            <a:fontRef idx="minor">
+              <a:schemeClr val="tx1"/>
+            </a:fontRef>
+          </p:style>
+        </p:cxnSp>
+      </p:grpSp>
+      <p:grpSp>
+        <p:nvGrpSpPr>
+          <p:cNvPr id="37" name="Group 36">
+            <a:extLst>
+              <a:ext uri="{FF2B5EF4-FFF2-40B4-BE49-F238E27FC236}">
+                <a16:creationId xmlns:a16="http://schemas.microsoft.com/office/drawing/2014/main" id="{8055EEE9-7560-904F-58BB-22E9321A58DF}"/>
+              </a:ext>
+            </a:extLst>
+          </p:cNvPr>
+          <p:cNvGrpSpPr/>
+          <p:nvPr/>
+        </p:nvGrpSpPr>
+        <p:grpSpPr>
+          <a:xfrm>
+            <a:off x="8251106" y="1192162"/>
+            <a:ext cx="1845" cy="5297129"/>
+            <a:chOff x="7965970" y="690716"/>
+            <a:chExt cx="1845" cy="5297129"/>
+          </a:xfrm>
+        </p:grpSpPr>
+        <p:cxnSp>
+          <p:nvCxnSpPr>
+            <p:cNvPr id="14" name="Straight Connector 13">
+              <a:extLst>
+                <a:ext uri="{FF2B5EF4-FFF2-40B4-BE49-F238E27FC236}">
+                  <a16:creationId xmlns:a16="http://schemas.microsoft.com/office/drawing/2014/main" id="{01CF956C-AD74-4544-F083-3082593F5118}"/>
+                </a:ext>
+              </a:extLst>
+            </p:cNvPr>
+            <p:cNvCxnSpPr>
+              <a:cxnSpLocks/>
+            </p:cNvCxnSpPr>
+            <p:nvPr/>
+          </p:nvCxnSpPr>
+          <p:spPr>
+            <a:xfrm>
+              <a:off x="7967815" y="690716"/>
+              <a:ext cx="0" cy="2286000"/>
+            </a:xfrm>
+            <a:prstGeom prst="line">
+              <a:avLst/>
+            </a:prstGeom>
+            <a:ln>
+              <a:solidFill>
+                <a:schemeClr val="tx1">
+                  <a:lumMod val="50000"/>
+                  <a:lumOff val="50000"/>
+                </a:schemeClr>
+              </a:solidFill>
+              <a:prstDash val="sysDash"/>
+            </a:ln>
+          </p:spPr>
+          <p:style>
+            <a:lnRef idx="2">
+              <a:schemeClr val="accent1"/>
+            </a:lnRef>
+            <a:fillRef idx="0">
+              <a:schemeClr val="accent1"/>
+            </a:fillRef>
+            <a:effectRef idx="1">
+              <a:schemeClr val="accent1"/>
+            </a:effectRef>
+            <a:fontRef idx="minor">
+              <a:schemeClr val="tx1"/>
+            </a:fontRef>
+          </p:style>
+        </p:cxnSp>
+        <p:cxnSp>
+          <p:nvCxnSpPr>
+            <p:cNvPr id="19" name="Straight Connector 18">
+              <a:extLst>
+                <a:ext uri="{FF2B5EF4-FFF2-40B4-BE49-F238E27FC236}">
+                  <a16:creationId xmlns:a16="http://schemas.microsoft.com/office/drawing/2014/main" id="{272060A5-119E-8A8A-0949-9B6D83631ADD}"/>
+                </a:ext>
+              </a:extLst>
+            </p:cNvPr>
+            <p:cNvCxnSpPr>
+              <a:cxnSpLocks/>
+            </p:cNvCxnSpPr>
+            <p:nvPr/>
+          </p:nvCxnSpPr>
+          <p:spPr>
+            <a:xfrm>
+              <a:off x="7965970" y="3701845"/>
+              <a:ext cx="0" cy="2286000"/>
+            </a:xfrm>
+            <a:prstGeom prst="line">
+              <a:avLst/>
+            </a:prstGeom>
+            <a:ln>
+              <a:solidFill>
+                <a:schemeClr val="tx1">
+                  <a:lumMod val="50000"/>
+                  <a:lumOff val="50000"/>
+                </a:schemeClr>
+              </a:solidFill>
+              <a:prstDash val="sysDash"/>
+            </a:ln>
+          </p:spPr>
+          <p:style>
+            <a:lnRef idx="2">
+              <a:schemeClr val="accent1"/>
+            </a:lnRef>
+            <a:fillRef idx="0">
+              <a:schemeClr val="accent1"/>
+            </a:fillRef>
+            <a:effectRef idx="1">
+              <a:schemeClr val="accent1"/>
+            </a:effectRef>
+            <a:fontRef idx="minor">
+              <a:schemeClr val="tx1"/>
+            </a:fontRef>
+          </p:style>
+        </p:cxnSp>
+      </p:grpSp>
+      <p:grpSp>
+        <p:nvGrpSpPr>
+          <p:cNvPr id="36" name="Group 35">
+            <a:extLst>
+              <a:ext uri="{FF2B5EF4-FFF2-40B4-BE49-F238E27FC236}">
+                <a16:creationId xmlns:a16="http://schemas.microsoft.com/office/drawing/2014/main" id="{1E229D33-00BC-CCB5-C486-68280254D4FD}"/>
+              </a:ext>
+            </a:extLst>
+          </p:cNvPr>
+          <p:cNvGrpSpPr/>
+          <p:nvPr/>
+        </p:nvGrpSpPr>
+        <p:grpSpPr>
+          <a:xfrm>
+            <a:off x="6480070" y="1192162"/>
+            <a:ext cx="1845" cy="5297129"/>
+            <a:chOff x="6194934" y="690716"/>
+            <a:chExt cx="1845" cy="5297129"/>
+          </a:xfrm>
+        </p:grpSpPr>
+        <p:cxnSp>
+          <p:nvCxnSpPr>
+            <p:cNvPr id="15" name="Straight Connector 14">
+              <a:extLst>
+                <a:ext uri="{FF2B5EF4-FFF2-40B4-BE49-F238E27FC236}">
+                  <a16:creationId xmlns:a16="http://schemas.microsoft.com/office/drawing/2014/main" id="{254011A8-5874-0AEC-885D-61FC767DF67B}"/>
+                </a:ext>
+              </a:extLst>
+            </p:cNvPr>
+            <p:cNvCxnSpPr>
+              <a:cxnSpLocks/>
+            </p:cNvCxnSpPr>
+            <p:nvPr/>
+          </p:nvCxnSpPr>
+          <p:spPr>
+            <a:xfrm>
+              <a:off x="6196779" y="690716"/>
+              <a:ext cx="0" cy="2286000"/>
+            </a:xfrm>
+            <a:prstGeom prst="line">
+              <a:avLst/>
+            </a:prstGeom>
+            <a:ln>
+              <a:solidFill>
+                <a:schemeClr val="bg1">
+                  <a:lumMod val="75000"/>
+                </a:schemeClr>
+              </a:solidFill>
+              <a:prstDash val="sysDash"/>
+            </a:ln>
+          </p:spPr>
+          <p:style>
+            <a:lnRef idx="2">
+              <a:schemeClr val="accent1"/>
+            </a:lnRef>
+            <a:fillRef idx="0">
+              <a:schemeClr val="accent1"/>
+            </a:fillRef>
+            <a:effectRef idx="1">
+              <a:schemeClr val="accent1"/>
+            </a:effectRef>
+            <a:fontRef idx="minor">
+              <a:schemeClr val="tx1"/>
+            </a:fontRef>
+          </p:style>
+        </p:cxnSp>
+        <p:cxnSp>
+          <p:nvCxnSpPr>
+            <p:cNvPr id="20" name="Straight Connector 19">
+              <a:extLst>
+                <a:ext uri="{FF2B5EF4-FFF2-40B4-BE49-F238E27FC236}">
+                  <a16:creationId xmlns:a16="http://schemas.microsoft.com/office/drawing/2014/main" id="{465E60D2-AFD0-9337-B39B-9B089EF8C9B2}"/>
+                </a:ext>
+              </a:extLst>
+            </p:cNvPr>
+            <p:cNvCxnSpPr>
+              <a:cxnSpLocks/>
+            </p:cNvCxnSpPr>
+            <p:nvPr/>
+          </p:nvCxnSpPr>
+          <p:spPr>
+            <a:xfrm>
+              <a:off x="6194934" y="3701845"/>
+              <a:ext cx="0" cy="2286000"/>
+            </a:xfrm>
+            <a:prstGeom prst="line">
+              <a:avLst/>
+            </a:prstGeom>
+            <a:ln>
+              <a:solidFill>
+                <a:schemeClr val="bg1">
+                  <a:lumMod val="75000"/>
+                </a:schemeClr>
+              </a:solidFill>
+              <a:prstDash val="sysDash"/>
+            </a:ln>
+          </p:spPr>
+          <p:style>
+            <a:lnRef idx="2">
+              <a:schemeClr val="accent1"/>
+            </a:lnRef>
+            <a:fillRef idx="0">
+              <a:schemeClr val="accent1"/>
+            </a:fillRef>
+            <a:effectRef idx="1">
+              <a:schemeClr val="accent1"/>
+            </a:effectRef>
+            <a:fontRef idx="minor">
+              <a:schemeClr val="tx1"/>
+            </a:fontRef>
+          </p:style>
+        </p:cxnSp>
+      </p:grpSp>
+      <p:sp>
+        <p:nvSpPr>
+          <p:cNvPr id="24" name="Rectangle 23">
+            <a:extLst>
+              <a:ext uri="{FF2B5EF4-FFF2-40B4-BE49-F238E27FC236}">
+                <a16:creationId xmlns:a16="http://schemas.microsoft.com/office/drawing/2014/main" id="{349A8C91-A357-5292-03F7-F4EDBDD86AD2}"/>
+              </a:ext>
+            </a:extLst>
+          </p:cNvPr>
+          <p:cNvSpPr>
+            <a:spLocks noChangeAspect="1"/>
+          </p:cNvSpPr>
+          <p:nvPr/>
+        </p:nvSpPr>
+        <p:spPr>
+          <a:xfrm>
+            <a:off x="5365952" y="4682613"/>
+            <a:ext cx="457200" cy="457200"/>
+          </a:xfrm>
+          <a:prstGeom prst="rect">
+            <a:avLst/>
+          </a:prstGeom>
+          <a:solidFill>
+            <a:srgbClr val="F0A1A0">
+              <a:alpha val="50000"/>
+            </a:srgbClr>
+          </a:solidFill>
+          <a:ln>
+            <a:solidFill>
+              <a:schemeClr val="tx1"/>
+            </a:solidFill>
+          </a:ln>
+        </p:spPr>
+        <p:style>
+          <a:lnRef idx="2">
+            <a:schemeClr val="accent1">
+              <a:shade val="15000"/>
+            </a:schemeClr>
+          </a:lnRef>
+          <a:fillRef idx="1">
+            <a:schemeClr val="accent1"/>
+          </a:fillRef>
+          <a:effectRef idx="0">
+            <a:schemeClr val="accent1"/>
+          </a:effectRef>
+          <a:fontRef idx="minor">
+            <a:schemeClr val="lt1"/>
+          </a:fontRef>
+        </p:style>
+        <p:txBody>
+          <a:bodyPr rtlCol="0" anchor="ctr"/>
+          <a:lstStyle/>
+          <a:p>
+            <a:pPr algn="ctr"/>
+            <a:endParaRPr lang="en-US"/>
+          </a:p>
+        </p:txBody>
+      </p:sp>
+      <p:sp>
+        <p:nvSpPr>
+          <p:cNvPr id="26" name="Rectangle 25">
+            <a:extLst>
+              <a:ext uri="{FF2B5EF4-FFF2-40B4-BE49-F238E27FC236}">
+                <a16:creationId xmlns:a16="http://schemas.microsoft.com/office/drawing/2014/main" id="{9254B039-ABB0-358A-B0DB-E6BB32314F19}"/>
+              </a:ext>
+            </a:extLst>
+          </p:cNvPr>
+          <p:cNvSpPr>
+            <a:spLocks noChangeAspect="1"/>
+          </p:cNvSpPr>
+          <p:nvPr/>
+        </p:nvSpPr>
+        <p:spPr>
+          <a:xfrm>
+            <a:off x="1314138" y="4682613"/>
+            <a:ext cx="457200" cy="457200"/>
+          </a:xfrm>
+          <a:prstGeom prst="rect">
+            <a:avLst/>
+          </a:prstGeom>
+          <a:solidFill>
+            <a:srgbClr val="F0A1A0"/>
+          </a:solidFill>
+          <a:ln>
+            <a:noFill/>
+          </a:ln>
+        </p:spPr>
+        <p:style>
+          <a:lnRef idx="2">
+            <a:schemeClr val="accent1">
+              <a:shade val="15000"/>
+            </a:schemeClr>
+          </a:lnRef>
+          <a:fillRef idx="1">
+            <a:schemeClr val="accent1"/>
+          </a:fillRef>
+          <a:effectRef idx="0">
+            <a:schemeClr val="accent1"/>
+          </a:effectRef>
+          <a:fontRef idx="minor">
+            <a:schemeClr val="lt1"/>
+          </a:fontRef>
+        </p:style>
+        <p:txBody>
+          <a:bodyPr rtlCol="0" anchor="ctr"/>
+          <a:lstStyle/>
+          <a:p>
+            <a:pPr algn="ctr"/>
+            <a:endParaRPr lang="en-US"/>
+          </a:p>
+        </p:txBody>
+      </p:sp>
+      <p:sp>
+        <p:nvSpPr>
+          <p:cNvPr id="27" name="Rectangle 26">
+            <a:extLst>
+              <a:ext uri="{FF2B5EF4-FFF2-40B4-BE49-F238E27FC236}">
+                <a16:creationId xmlns:a16="http://schemas.microsoft.com/office/drawing/2014/main" id="{DB2DD793-B37E-69E5-EC32-E46D935A25D0}"/>
+              </a:ext>
+            </a:extLst>
+          </p:cNvPr>
+          <p:cNvSpPr>
+            <a:spLocks noChangeAspect="1"/>
+          </p:cNvSpPr>
+          <p:nvPr/>
+        </p:nvSpPr>
+        <p:spPr>
+          <a:xfrm>
+            <a:off x="732806" y="4682613"/>
+            <a:ext cx="457200" cy="457200"/>
+          </a:xfrm>
+          <a:prstGeom prst="rect">
+            <a:avLst/>
+          </a:prstGeom>
+          <a:solidFill>
+            <a:srgbClr val="F0A1A0"/>
+          </a:solidFill>
+          <a:ln>
+            <a:noFill/>
+          </a:ln>
+        </p:spPr>
+        <p:style>
+          <a:lnRef idx="2">
+            <a:schemeClr val="accent1">
+              <a:shade val="15000"/>
+            </a:schemeClr>
+          </a:lnRef>
+          <a:fillRef idx="1">
+            <a:schemeClr val="accent1"/>
+          </a:fillRef>
+          <a:effectRef idx="0">
+            <a:schemeClr val="accent1"/>
+          </a:effectRef>
+          <a:fontRef idx="minor">
+            <a:schemeClr val="lt1"/>
+          </a:fontRef>
+        </p:style>
+        <p:txBody>
+          <a:bodyPr rtlCol="0" anchor="ctr"/>
+          <a:lstStyle/>
+          <a:p>
+            <a:pPr algn="ctr"/>
+            <a:endParaRPr lang="en-US"/>
+          </a:p>
+        </p:txBody>
+      </p:sp>
+      <p:sp>
+        <p:nvSpPr>
+          <p:cNvPr id="28" name="Rectangle 27">
+            <a:extLst>
+              <a:ext uri="{FF2B5EF4-FFF2-40B4-BE49-F238E27FC236}">
+                <a16:creationId xmlns:a16="http://schemas.microsoft.com/office/drawing/2014/main" id="{9F314FA1-DBFF-BCAC-5BB5-B6717FCACEBB}"/>
+              </a:ext>
+            </a:extLst>
+          </p:cNvPr>
+          <p:cNvSpPr>
+            <a:spLocks noChangeAspect="1"/>
+          </p:cNvSpPr>
+          <p:nvPr/>
+        </p:nvSpPr>
+        <p:spPr>
+          <a:xfrm>
+            <a:off x="2833530" y="5254114"/>
+            <a:ext cx="457200" cy="457200"/>
+          </a:xfrm>
+          <a:prstGeom prst="rect">
+            <a:avLst/>
+          </a:prstGeom>
+          <a:solidFill>
+            <a:srgbClr val="F0A1A0">
+              <a:alpha val="75000"/>
+            </a:srgbClr>
+          </a:solidFill>
+          <a:ln>
+            <a:noFill/>
+          </a:ln>
+        </p:spPr>
+        <p:style>
+          <a:lnRef idx="2">
+            <a:schemeClr val="accent1">
+              <a:shade val="15000"/>
+            </a:schemeClr>
+          </a:lnRef>
+          <a:fillRef idx="1">
+            <a:schemeClr val="accent1"/>
+          </a:fillRef>
+          <a:effectRef idx="0">
+            <a:schemeClr val="accent1"/>
+          </a:effectRef>
+          <a:fontRef idx="minor">
+            <a:schemeClr val="lt1"/>
+          </a:fontRef>
+        </p:style>
+        <p:txBody>
+          <a:bodyPr rtlCol="0" anchor="ctr"/>
+          <a:lstStyle/>
+          <a:p>
+            <a:pPr algn="ctr"/>
+            <a:endParaRPr lang="en-US"/>
+          </a:p>
+        </p:txBody>
+      </p:sp>
+      <p:sp>
+        <p:nvSpPr>
+          <p:cNvPr id="29" name="Rectangle 28">
+            <a:extLst>
+              <a:ext uri="{FF2B5EF4-FFF2-40B4-BE49-F238E27FC236}">
+                <a16:creationId xmlns:a16="http://schemas.microsoft.com/office/drawing/2014/main" id="{14278AA6-763E-CDE0-EAB1-CD7D720BBC16}"/>
+              </a:ext>
+            </a:extLst>
+          </p:cNvPr>
+          <p:cNvSpPr>
+            <a:spLocks noChangeAspect="1"/>
+          </p:cNvSpPr>
+          <p:nvPr/>
+        </p:nvSpPr>
+        <p:spPr>
+          <a:xfrm>
+            <a:off x="3998039" y="4682613"/>
+            <a:ext cx="457200" cy="457200"/>
+          </a:xfrm>
+          <a:prstGeom prst="rect">
+            <a:avLst/>
+          </a:prstGeom>
+          <a:solidFill>
+            <a:srgbClr val="F0A1A0">
+              <a:alpha val="75000"/>
+            </a:srgbClr>
+          </a:solidFill>
+          <a:ln>
+            <a:noFill/>
+          </a:ln>
+        </p:spPr>
+        <p:style>
+          <a:lnRef idx="2">
+            <a:schemeClr val="accent1">
+              <a:shade val="15000"/>
+            </a:schemeClr>
+          </a:lnRef>
+          <a:fillRef idx="1">
+            <a:schemeClr val="accent1"/>
+          </a:fillRef>
+          <a:effectRef idx="0">
+            <a:schemeClr val="accent1"/>
+          </a:effectRef>
+          <a:fontRef idx="minor">
+            <a:schemeClr val="lt1"/>
+          </a:fontRef>
+        </p:style>
+        <p:txBody>
+          <a:bodyPr rtlCol="0" anchor="ctr"/>
+          <a:lstStyle/>
+          <a:p>
+            <a:pPr algn="ctr"/>
+            <a:endParaRPr lang="en-US"/>
+          </a:p>
+        </p:txBody>
+      </p:sp>
+      <p:sp>
+        <p:nvSpPr>
+          <p:cNvPr id="30" name="Rectangle 29">
+            <a:extLst>
+              <a:ext uri="{FF2B5EF4-FFF2-40B4-BE49-F238E27FC236}">
+                <a16:creationId xmlns:a16="http://schemas.microsoft.com/office/drawing/2014/main" id="{D1E194EC-3B39-6E3F-AEAA-C31A454BB065}"/>
+              </a:ext>
+            </a:extLst>
+          </p:cNvPr>
+          <p:cNvSpPr>
+            <a:spLocks noChangeAspect="1"/>
+          </p:cNvSpPr>
+          <p:nvPr/>
+        </p:nvSpPr>
+        <p:spPr>
+          <a:xfrm>
+            <a:off x="3416707" y="4682613"/>
+            <a:ext cx="457200" cy="457200"/>
+          </a:xfrm>
+          <a:prstGeom prst="rect">
+            <a:avLst/>
+          </a:prstGeom>
+          <a:solidFill>
+            <a:srgbClr val="F0A1A0">
+              <a:alpha val="75000"/>
+            </a:srgbClr>
+          </a:solidFill>
+          <a:ln>
+            <a:noFill/>
+          </a:ln>
+        </p:spPr>
+        <p:style>
+          <a:lnRef idx="2">
+            <a:schemeClr val="accent1">
+              <a:shade val="15000"/>
+            </a:schemeClr>
+          </a:lnRef>
+          <a:fillRef idx="1">
+            <a:schemeClr val="accent1"/>
+          </a:fillRef>
+          <a:effectRef idx="0">
+            <a:schemeClr val="accent1"/>
+          </a:effectRef>
+          <a:fontRef idx="minor">
+            <a:schemeClr val="lt1"/>
+          </a:fontRef>
+        </p:style>
+        <p:txBody>
+          <a:bodyPr rtlCol="0" anchor="ctr"/>
+          <a:lstStyle/>
+          <a:p>
+            <a:pPr algn="ctr"/>
+            <a:endParaRPr lang="en-US"/>
+          </a:p>
+        </p:txBody>
+      </p:sp>
+      <p:sp>
+        <p:nvSpPr>
+          <p:cNvPr id="31" name="Rectangle 30">
+            <a:extLst>
+              <a:ext uri="{FF2B5EF4-FFF2-40B4-BE49-F238E27FC236}">
+                <a16:creationId xmlns:a16="http://schemas.microsoft.com/office/drawing/2014/main" id="{D833D258-55E3-96CE-46DA-64240CB23470}"/>
+              </a:ext>
+            </a:extLst>
+          </p:cNvPr>
+          <p:cNvSpPr>
+            <a:spLocks noChangeAspect="1"/>
+          </p:cNvSpPr>
+          <p:nvPr/>
+        </p:nvSpPr>
+        <p:spPr>
+          <a:xfrm>
+            <a:off x="2835375" y="4682613"/>
+            <a:ext cx="457200" cy="457200"/>
+          </a:xfrm>
+          <a:prstGeom prst="rect">
+            <a:avLst/>
+          </a:prstGeom>
+          <a:solidFill>
+            <a:srgbClr val="F0A1A0">
+              <a:alpha val="75000"/>
+            </a:srgbClr>
+          </a:solidFill>
+          <a:ln>
+            <a:noFill/>
+          </a:ln>
+        </p:spPr>
+        <p:style>
+          <a:lnRef idx="2">
+            <a:schemeClr val="accent1">
+              <a:shade val="15000"/>
+            </a:schemeClr>
+          </a:lnRef>
+          <a:fillRef idx="1">
+            <a:schemeClr val="accent1"/>
+          </a:fillRef>
+          <a:effectRef idx="0">
+            <a:schemeClr val="accent1"/>
+          </a:effectRef>
+          <a:fontRef idx="minor">
+            <a:schemeClr val="lt1"/>
+          </a:fontRef>
+        </p:style>
+        <p:txBody>
+          <a:bodyPr rtlCol="0" anchor="ctr"/>
+          <a:lstStyle/>
+          <a:p>
+            <a:pPr algn="ctr"/>
+            <a:endParaRPr lang="en-US"/>
+          </a:p>
+        </p:txBody>
+      </p:sp>
+      <p:sp>
+        <p:nvSpPr>
+          <p:cNvPr id="32" name="TextBox 31">
+            <a:extLst>
+              <a:ext uri="{FF2B5EF4-FFF2-40B4-BE49-F238E27FC236}">
+                <a16:creationId xmlns:a16="http://schemas.microsoft.com/office/drawing/2014/main" id="{4D2DF96C-60C7-BDF1-01D5-3981367FF302}"/>
+              </a:ext>
+            </a:extLst>
+          </p:cNvPr>
+          <p:cNvSpPr txBox="1"/>
+          <p:nvPr/>
+        </p:nvSpPr>
+        <p:spPr>
+          <a:xfrm>
+            <a:off x="5682736" y="734340"/>
+            <a:ext cx="1594667" cy="369332"/>
+          </a:xfrm>
+          <a:prstGeom prst="rect">
+            <a:avLst/>
+          </a:prstGeom>
+          <a:noFill/>
+        </p:spPr>
+        <p:txBody>
+          <a:bodyPr wrap="none" rtlCol="0">
+            <a:spAutoFit/>
+          </a:bodyPr>
+          <a:lstStyle/>
+          <a:p>
+            <a:pPr algn="ctr"/>
+            <a:r>
+              <a:rPr lang="en-US" b="1" dirty="0"/>
+              <a:t>2024 districts</a:t>
+            </a:r>
+          </a:p>
+        </p:txBody>
+      </p:sp>
+      <p:sp>
+        <p:nvSpPr>
+          <p:cNvPr id="33" name="TextBox 32">
+            <a:extLst>
+              <a:ext uri="{FF2B5EF4-FFF2-40B4-BE49-F238E27FC236}">
+                <a16:creationId xmlns:a16="http://schemas.microsoft.com/office/drawing/2014/main" id="{07C11EAC-E0E8-09EE-E811-C086F9B2A0CE}"/>
+              </a:ext>
+            </a:extLst>
+          </p:cNvPr>
+          <p:cNvSpPr txBox="1"/>
+          <p:nvPr/>
+        </p:nvSpPr>
+        <p:spPr>
+          <a:xfrm>
+            <a:off x="5312240" y="3699994"/>
+            <a:ext cx="2640466" cy="369332"/>
+          </a:xfrm>
+          <a:prstGeom prst="rect">
+            <a:avLst/>
+          </a:prstGeom>
+          <a:noFill/>
+        </p:spPr>
+        <p:txBody>
+          <a:bodyPr wrap="none" rtlCol="0">
+            <a:spAutoFit/>
+          </a:bodyPr>
+          <a:lstStyle/>
+          <a:p>
+            <a:pPr algn="ctr"/>
+            <a:r>
+              <a:rPr lang="en-US" b="1" dirty="0"/>
+              <a:t>2026 proposed districts</a:t>
+            </a:r>
+          </a:p>
+        </p:txBody>
+      </p:sp>
+      <p:sp>
+        <p:nvSpPr>
+          <p:cNvPr id="39" name="TextBox 38">
+            <a:extLst>
+              <a:ext uri="{FF2B5EF4-FFF2-40B4-BE49-F238E27FC236}">
+                <a16:creationId xmlns:a16="http://schemas.microsoft.com/office/drawing/2014/main" id="{E2DCFFB8-8485-CA24-8F11-E1EC1A00176C}"/>
+              </a:ext>
+            </a:extLst>
+          </p:cNvPr>
+          <p:cNvSpPr txBox="1"/>
+          <p:nvPr/>
+        </p:nvSpPr>
+        <p:spPr>
+          <a:xfrm>
+            <a:off x="558931" y="6489291"/>
+            <a:ext cx="1510413" cy="369332"/>
+          </a:xfrm>
+          <a:prstGeom prst="rect">
+            <a:avLst/>
+          </a:prstGeom>
+          <a:noFill/>
+        </p:spPr>
+        <p:txBody>
+          <a:bodyPr wrap="none" rtlCol="0">
+            <a:spAutoFit/>
+          </a:bodyPr>
+          <a:lstStyle/>
+          <a:p>
+            <a:pPr algn="ctr"/>
+            <a:r>
+              <a:rPr lang="en-US" dirty="0">
+                <a:solidFill>
+                  <a:schemeClr val="bg1">
+                    <a:lumMod val="85000"/>
+                  </a:schemeClr>
+                </a:solidFill>
+              </a:rPr>
+              <a:t>R</a:t>
+            </a:r>
+            <a:r>
+              <a:rPr lang="en-US" baseline="30000" dirty="0">
+                <a:solidFill>
+                  <a:schemeClr val="bg1">
+                    <a:lumMod val="85000"/>
+                  </a:schemeClr>
+                </a:solidFill>
+              </a:rPr>
+              <a:t>+</a:t>
+            </a:r>
+            <a:r>
+              <a:rPr lang="en-US" dirty="0">
+                <a:solidFill>
+                  <a:schemeClr val="bg1">
+                    <a:lumMod val="85000"/>
+                  </a:schemeClr>
+                </a:solidFill>
+              </a:rPr>
+              <a:t>20 or more</a:t>
+            </a:r>
+          </a:p>
+        </p:txBody>
+      </p:sp>
+      <p:sp>
+        <p:nvSpPr>
+          <p:cNvPr id="41" name="TextBox 40">
+            <a:extLst>
+              <a:ext uri="{FF2B5EF4-FFF2-40B4-BE49-F238E27FC236}">
+                <a16:creationId xmlns:a16="http://schemas.microsoft.com/office/drawing/2014/main" id="{7EE2928D-72CF-D907-557A-3E4FFA16540D}"/>
+              </a:ext>
+            </a:extLst>
+          </p:cNvPr>
+          <p:cNvSpPr txBox="1"/>
+          <p:nvPr/>
+        </p:nvSpPr>
+        <p:spPr>
+          <a:xfrm>
+            <a:off x="3135526" y="6489291"/>
+            <a:ext cx="1013418" cy="369332"/>
+          </a:xfrm>
+          <a:prstGeom prst="rect">
+            <a:avLst/>
+          </a:prstGeom>
+          <a:noFill/>
+        </p:spPr>
+        <p:txBody>
+          <a:bodyPr wrap="none" rtlCol="0">
+            <a:spAutoFit/>
+          </a:bodyPr>
+          <a:lstStyle/>
+          <a:p>
+            <a:pPr algn="ctr"/>
+            <a:r>
+              <a:rPr lang="en-US" baseline="30000" dirty="0">
+                <a:solidFill>
+                  <a:schemeClr val="bg1">
+                    <a:lumMod val="85000"/>
+                  </a:schemeClr>
+                </a:solidFill>
+              </a:rPr>
+              <a:t>+</a:t>
+            </a:r>
+            <a:r>
+              <a:rPr lang="en-US" dirty="0">
+                <a:solidFill>
+                  <a:schemeClr val="bg1">
+                    <a:lumMod val="85000"/>
+                  </a:schemeClr>
+                </a:solidFill>
+              </a:rPr>
+              <a:t>10 - </a:t>
+            </a:r>
+            <a:r>
+              <a:rPr lang="en-US" baseline="30000" dirty="0">
+                <a:solidFill>
+                  <a:schemeClr val="bg1">
+                    <a:lumMod val="85000"/>
+                  </a:schemeClr>
+                </a:solidFill>
+              </a:rPr>
+              <a:t>+</a:t>
+            </a:r>
+            <a:r>
+              <a:rPr lang="en-US" dirty="0">
+                <a:solidFill>
+                  <a:schemeClr val="bg1">
+                    <a:lumMod val="85000"/>
+                  </a:schemeClr>
+                </a:solidFill>
+              </a:rPr>
+              <a:t>20</a:t>
+            </a:r>
+          </a:p>
+        </p:txBody>
+      </p:sp>
+      <p:sp>
+        <p:nvSpPr>
+          <p:cNvPr id="42" name="TextBox 41">
+            <a:extLst>
+              <a:ext uri="{FF2B5EF4-FFF2-40B4-BE49-F238E27FC236}">
+                <a16:creationId xmlns:a16="http://schemas.microsoft.com/office/drawing/2014/main" id="{692E12CA-5975-F777-3231-6CCE9ACADF02}"/>
+              </a:ext>
+            </a:extLst>
+          </p:cNvPr>
+          <p:cNvSpPr txBox="1"/>
+          <p:nvPr/>
+        </p:nvSpPr>
+        <p:spPr>
+          <a:xfrm>
+            <a:off x="4741306" y="6489291"/>
+            <a:ext cx="1706493" cy="369332"/>
+          </a:xfrm>
+          <a:prstGeom prst="rect">
+            <a:avLst/>
+          </a:prstGeom>
+          <a:noFill/>
+        </p:spPr>
+        <p:txBody>
+          <a:bodyPr wrap="none" rtlCol="0">
+            <a:spAutoFit/>
+          </a:bodyPr>
+          <a:lstStyle/>
+          <a:p>
+            <a:pPr algn="ctr"/>
+            <a:r>
+              <a:rPr lang="en-US" dirty="0">
+                <a:solidFill>
+                  <a:schemeClr val="bg1">
+                    <a:lumMod val="85000"/>
+                  </a:schemeClr>
+                </a:solidFill>
+              </a:rPr>
+              <a:t>Less than R</a:t>
+            </a:r>
+            <a:r>
+              <a:rPr lang="en-US" baseline="30000" dirty="0">
+                <a:solidFill>
+                  <a:schemeClr val="bg1">
+                    <a:lumMod val="85000"/>
+                  </a:schemeClr>
+                </a:solidFill>
+              </a:rPr>
+              <a:t>+</a:t>
+            </a:r>
+            <a:r>
+              <a:rPr lang="en-US" dirty="0">
+                <a:solidFill>
+                  <a:schemeClr val="bg1">
+                    <a:lumMod val="85000"/>
+                  </a:schemeClr>
+                </a:solidFill>
+              </a:rPr>
+              <a:t>10</a:t>
+            </a:r>
+          </a:p>
+        </p:txBody>
+      </p:sp>
+      <p:sp>
+        <p:nvSpPr>
+          <p:cNvPr id="43" name="TextBox 42">
+            <a:extLst>
+              <a:ext uri="{FF2B5EF4-FFF2-40B4-BE49-F238E27FC236}">
+                <a16:creationId xmlns:a16="http://schemas.microsoft.com/office/drawing/2014/main" id="{698CA84B-B52E-83C4-86CC-0C11287D8676}"/>
+              </a:ext>
+            </a:extLst>
+          </p:cNvPr>
+          <p:cNvSpPr txBox="1"/>
+          <p:nvPr/>
+        </p:nvSpPr>
+        <p:spPr>
+          <a:xfrm>
+            <a:off x="6510262" y="6489291"/>
+            <a:ext cx="1679242" cy="369332"/>
+          </a:xfrm>
+          <a:prstGeom prst="rect">
+            <a:avLst/>
+          </a:prstGeom>
+          <a:noFill/>
+        </p:spPr>
+        <p:txBody>
+          <a:bodyPr wrap="none" rtlCol="0">
+            <a:spAutoFit/>
+          </a:bodyPr>
+          <a:lstStyle/>
+          <a:p>
+            <a:pPr algn="ctr"/>
+            <a:r>
+              <a:rPr lang="en-US" dirty="0">
+                <a:solidFill>
+                  <a:schemeClr val="bg1">
+                    <a:lumMod val="85000"/>
+                  </a:schemeClr>
+                </a:solidFill>
+              </a:rPr>
+              <a:t>Less than D</a:t>
+            </a:r>
+            <a:r>
+              <a:rPr lang="en-US" baseline="30000" dirty="0">
+                <a:solidFill>
+                  <a:schemeClr val="bg1">
+                    <a:lumMod val="85000"/>
+                  </a:schemeClr>
+                </a:solidFill>
+              </a:rPr>
+              <a:t>+</a:t>
+            </a:r>
+            <a:r>
+              <a:rPr lang="en-US" dirty="0">
+                <a:solidFill>
+                  <a:schemeClr val="bg1">
+                    <a:lumMod val="85000"/>
+                  </a:schemeClr>
+                </a:solidFill>
+              </a:rPr>
+              <a:t>10</a:t>
+            </a:r>
+          </a:p>
+        </p:txBody>
+      </p:sp>
+      <p:sp>
+        <p:nvSpPr>
+          <p:cNvPr id="44" name="TextBox 43">
+            <a:extLst>
+              <a:ext uri="{FF2B5EF4-FFF2-40B4-BE49-F238E27FC236}">
+                <a16:creationId xmlns:a16="http://schemas.microsoft.com/office/drawing/2014/main" id="{CDC8E3F4-921C-3EDA-2739-43AB92A18467}"/>
+              </a:ext>
+            </a:extLst>
+          </p:cNvPr>
+          <p:cNvSpPr txBox="1"/>
+          <p:nvPr/>
+        </p:nvSpPr>
+        <p:spPr>
+          <a:xfrm>
+            <a:off x="8604376" y="6489291"/>
+            <a:ext cx="1013418" cy="369332"/>
+          </a:xfrm>
+          <a:prstGeom prst="rect">
+            <a:avLst/>
+          </a:prstGeom>
+          <a:noFill/>
+        </p:spPr>
+        <p:txBody>
+          <a:bodyPr wrap="none" rtlCol="0">
+            <a:spAutoFit/>
+          </a:bodyPr>
+          <a:lstStyle/>
+          <a:p>
+            <a:pPr algn="ctr"/>
+            <a:r>
+              <a:rPr lang="en-US" baseline="30000" dirty="0">
+                <a:solidFill>
+                  <a:schemeClr val="bg1">
+                    <a:lumMod val="85000"/>
+                  </a:schemeClr>
+                </a:solidFill>
+              </a:rPr>
+              <a:t>+</a:t>
+            </a:r>
+            <a:r>
+              <a:rPr lang="en-US" dirty="0">
+                <a:solidFill>
+                  <a:schemeClr val="bg1">
+                    <a:lumMod val="85000"/>
+                  </a:schemeClr>
+                </a:solidFill>
+              </a:rPr>
+              <a:t>10 - </a:t>
+            </a:r>
+            <a:r>
+              <a:rPr lang="en-US" baseline="30000" dirty="0">
+                <a:solidFill>
+                  <a:schemeClr val="bg1">
+                    <a:lumMod val="85000"/>
+                  </a:schemeClr>
+                </a:solidFill>
+              </a:rPr>
+              <a:t>+</a:t>
+            </a:r>
+            <a:r>
+              <a:rPr lang="en-US" dirty="0">
+                <a:solidFill>
+                  <a:schemeClr val="bg1">
+                    <a:lumMod val="85000"/>
+                  </a:schemeClr>
+                </a:solidFill>
+              </a:rPr>
+              <a:t>20</a:t>
+            </a:r>
+          </a:p>
+        </p:txBody>
+      </p:sp>
+      <p:sp>
+        <p:nvSpPr>
+          <p:cNvPr id="45" name="TextBox 44">
+            <a:extLst>
+              <a:ext uri="{FF2B5EF4-FFF2-40B4-BE49-F238E27FC236}">
+                <a16:creationId xmlns:a16="http://schemas.microsoft.com/office/drawing/2014/main" id="{89B740A8-592E-04BD-3910-1FAECD00046E}"/>
+              </a:ext>
+            </a:extLst>
+          </p:cNvPr>
+          <p:cNvSpPr txBox="1"/>
+          <p:nvPr/>
+        </p:nvSpPr>
+        <p:spPr>
+          <a:xfrm>
+            <a:off x="10109750" y="6489291"/>
+            <a:ext cx="1510413" cy="369332"/>
+          </a:xfrm>
+          <a:prstGeom prst="rect">
+            <a:avLst/>
+          </a:prstGeom>
+          <a:noFill/>
+        </p:spPr>
+        <p:txBody>
+          <a:bodyPr wrap="none" rtlCol="0">
+            <a:spAutoFit/>
+          </a:bodyPr>
+          <a:lstStyle/>
+          <a:p>
+            <a:pPr algn="ctr"/>
+            <a:r>
+              <a:rPr lang="en-US" dirty="0">
+                <a:solidFill>
+                  <a:schemeClr val="bg1">
+                    <a:lumMod val="85000"/>
+                  </a:schemeClr>
+                </a:solidFill>
+              </a:rPr>
+              <a:t>D</a:t>
+            </a:r>
+            <a:r>
+              <a:rPr lang="en-US" baseline="30000" dirty="0">
+                <a:solidFill>
+                  <a:schemeClr val="bg1">
+                    <a:lumMod val="85000"/>
+                  </a:schemeClr>
+                </a:solidFill>
+              </a:rPr>
+              <a:t>+</a:t>
+            </a:r>
+            <a:r>
+              <a:rPr lang="en-US" dirty="0">
+                <a:solidFill>
+                  <a:schemeClr val="bg1">
+                    <a:lumMod val="85000"/>
+                  </a:schemeClr>
+                </a:solidFill>
+              </a:rPr>
+              <a:t>20 or more</a:t>
+            </a:r>
+          </a:p>
+        </p:txBody>
+      </p:sp>
+      <p:sp>
+        <p:nvSpPr>
+          <p:cNvPr id="47" name="TextBox 46">
+            <a:extLst>
+              <a:ext uri="{FF2B5EF4-FFF2-40B4-BE49-F238E27FC236}">
+                <a16:creationId xmlns:a16="http://schemas.microsoft.com/office/drawing/2014/main" id="{F4076CCA-F768-7205-5587-30EBCB0FAA47}"/>
+              </a:ext>
+            </a:extLst>
+          </p:cNvPr>
+          <p:cNvSpPr txBox="1"/>
+          <p:nvPr/>
+        </p:nvSpPr>
+        <p:spPr>
+          <a:xfrm>
+            <a:off x="5078578" y="205692"/>
+            <a:ext cx="2738442" cy="461665"/>
+          </a:xfrm>
+          <a:prstGeom prst="rect">
+            <a:avLst/>
+          </a:prstGeom>
+          <a:noFill/>
+        </p:spPr>
+        <p:txBody>
+          <a:bodyPr wrap="none" rtlCol="0">
+            <a:spAutoFit/>
+          </a:bodyPr>
+          <a:lstStyle/>
+          <a:p>
+            <a:pPr algn="ctr"/>
+            <a:r>
+              <a:rPr lang="en-US" sz="2400" b="1" dirty="0"/>
+              <a:t>SOUTH CAROLINA</a:t>
+            </a:r>
+          </a:p>
+        </p:txBody>
+      </p:sp>
+    </p:spTree>
+    <p:extLst>
+      <p:ext uri="{BB962C8B-B14F-4D97-AF65-F5344CB8AC3E}">
+        <p14:creationId xmlns:p14="http://schemas.microsoft.com/office/powerpoint/2010/main" val="3064987651"/>
       </p:ext>
     </p:extLst>
   </p:cSld>

</xml_diff>